<commit_message>
fix: korrigiere Schreibfehler in deutschen Texten und verbessere Kommentare
</commit_message>
<xml_diff>
--- a/frontend/Mage.pptx
+++ b/frontend/Mage.pptx
@@ -5774,14 +5774,48 @@
           </a:bodyPr>
           <a:lstStyle/>
           <a:p>
-            <a:r>
-              <a:rPr lang="de-DE" sz="1800">
+            <a:pPr marL="285750" indent="-285750">
+              <a:buFontTx/>
+              <a:buChar char="-"/>
+            </a:pPr>
+            <a:r>
+              <a:rPr lang="de-DE" sz="1800" dirty="0">
                 <a:solidFill>
                   <a:srgbClr val="FFFFFF"/>
                 </a:solidFill>
                 <a:latin typeface="Source Sans 3"/>
               </a:rPr>
-              <a:t>- Klare Aufgaben und Verantwortungen\n- Transparente Status fuer Manager\n- Weniger Reibung im Arbeitsalltag</a:t>
+              <a:t>Klare Aufgaben und Verantwortungen</a:t>
+            </a:r>
+          </a:p>
+          <a:p>
+            <a:pPr marL="285750" indent="-285750">
+              <a:buFontTx/>
+              <a:buChar char="-"/>
+            </a:pPr>
+            <a:r>
+              <a:rPr lang="de-DE" sz="1800" dirty="0">
+                <a:solidFill>
+                  <a:srgbClr val="FFFFFF"/>
+                </a:solidFill>
+                <a:latin typeface="Source Sans 3"/>
+              </a:rPr>
+              <a:t>Transparente Status für Manager</a:t>
+            </a:r>
+          </a:p>
+          <a:p>
+            <a:pPr marL="285750" indent="-285750">
+              <a:buFontTx/>
+              <a:buChar char="-"/>
+            </a:pPr>
+            <a:r>
+              <a:rPr lang="de-DE" sz="1800" dirty="0">
+                <a:solidFill>
+                  <a:srgbClr val="FFFFFF"/>
+                </a:solidFill>
+                <a:latin typeface="Source Sans 3"/>
+              </a:rPr>
+              <a:t>Weniger Reibung im Arbeitsalltag</a:t>
             </a:r>
           </a:p>
         </p:txBody>
@@ -5800,8 +5834,8 @@
         </p:nvSpPr>
         <p:spPr>
           <a:xfrm>
-            <a:off x="5303520" y="1778000"/>
-            <a:ext cx="3230880" cy="2540000"/>
+            <a:off x="5303520" y="1201316"/>
+            <a:ext cx="3230880" cy="1656184"/>
           </a:xfrm>
           <a:prstGeom prst="roundRect">
             <a:avLst/>
@@ -5854,7 +5888,7 @@
         </p:nvSpPr>
         <p:spPr>
           <a:xfrm>
-            <a:off x="5506720" y="1955800"/>
+            <a:off x="5506720" y="1379116"/>
             <a:ext cx="2824480" cy="369332"/>
           </a:xfrm>
           <a:prstGeom prst="rect">
@@ -5869,13 +5903,13 @@
           <a:lstStyle/>
           <a:p>
             <a:r>
-              <a:rPr lang="de-DE" sz="1800" b="1">
+              <a:rPr lang="de-DE" sz="1800" b="1" dirty="0">
                 <a:solidFill>
                   <a:srgbClr val="4C8BFF"/>
                 </a:solidFill>
                 <a:latin typeface="Source Sans 3"/>
               </a:rPr>
-              <a:t>Naechste Schritte</a:t>
+              <a:t>Nächste Schritte</a:t>
             </a:r>
           </a:p>
         </p:txBody>
@@ -5894,8 +5928,8 @@
         </p:nvSpPr>
         <p:spPr>
           <a:xfrm>
-            <a:off x="5506720" y="2362200"/>
-            <a:ext cx="2824480" cy="584775"/>
+            <a:off x="5506720" y="1778000"/>
+            <a:ext cx="2824480" cy="923330"/>
           </a:xfrm>
           <a:prstGeom prst="rect">
             <a:avLst/>
@@ -5908,21 +5942,49 @@
           </a:bodyPr>
           <a:lstStyle/>
           <a:p>
-            <a:r>
-              <a:rPr lang="sv-SE" sz="1600">
+            <a:pPr marL="285750" indent="-285750">
+              <a:buFontTx/>
+              <a:buChar char="-"/>
+            </a:pPr>
+            <a:r>
+              <a:rPr lang="sv-SE" sz="1600" dirty="0">
                 <a:solidFill>
                   <a:srgbClr val="FFFFFF"/>
                 </a:solidFill>
                 <a:latin typeface="Source Sans 3"/>
               </a:rPr>
-              <a:t>- Pilotteam starten\n- Feedback sammeln\n- Rollout planen</a:t>
-            </a:r>
-            <a:endParaRPr lang="de-DE" sz="1600">
-              <a:solidFill>
-                <a:srgbClr val="FFFFFF"/>
-              </a:solidFill>
-              <a:latin typeface="Source Sans 3"/>
-            </a:endParaRPr>
+              <a:t>Benachrichtigung einstellen</a:t>
+            </a:r>
+          </a:p>
+          <a:p>
+            <a:pPr marL="285750" indent="-285750">
+              <a:buFontTx/>
+              <a:buChar char="-"/>
+            </a:pPr>
+            <a:r>
+              <a:rPr lang="sv-SE" sz="1600" dirty="0">
+                <a:solidFill>
+                  <a:srgbClr val="FFFFFF"/>
+                </a:solidFill>
+                <a:latin typeface="Source Sans 3"/>
+              </a:rPr>
+              <a:t>UI intuitiver gestalten</a:t>
+            </a:r>
+          </a:p>
+          <a:p>
+            <a:pPr marL="285750" indent="-285750">
+              <a:buFontTx/>
+              <a:buChar char="-"/>
+            </a:pPr>
+            <a:r>
+              <a:rPr lang="sv-SE" sz="1600" dirty="0">
+                <a:solidFill>
+                  <a:srgbClr val="FFFFFF"/>
+                </a:solidFill>
+                <a:latin typeface="Source Sans 3"/>
+              </a:rPr>
+              <a:t>Haptic Feedback</a:t>
+            </a:r>
           </a:p>
         </p:txBody>
       </p:sp>
@@ -7295,50 +7357,10 @@
       </p:grpSpPr>
       <p:sp>
         <p:nvSpPr>
-          <p:cNvPr id="2" name="Textfeld 1">
-            <a:extLst>
-              <a:ext uri="{FF2B5EF4-FFF2-40B4-BE49-F238E27FC236}">
-                <a16:creationId xmlns:a16="http://schemas.microsoft.com/office/drawing/2014/main" id="{5A1D0970-09E7-5792-FDDA-5C7C29B6A91F}"/>
-              </a:ext>
-            </a:extLst>
-          </p:cNvPr>
-          <p:cNvSpPr txBox="1"/>
-          <p:nvPr/>
-        </p:nvSpPr>
-        <p:spPr>
-          <a:xfrm>
-            <a:off x="609600" y="508000"/>
-            <a:ext cx="5486400" cy="615553"/>
-          </a:xfrm>
-          <a:prstGeom prst="rect">
-            <a:avLst/>
-          </a:prstGeom>
-          <a:noFill/>
-        </p:spPr>
-        <p:txBody>
-          <a:bodyPr vert="horz" wrap="square" rtlCol="0">
-            <a:noAutofit/>
-          </a:bodyPr>
-          <a:lstStyle/>
-          <a:p>
-            <a:r>
-              <a:rPr lang="de-DE" sz="3400" b="1">
-                <a:solidFill>
-                  <a:srgbClr val="FFFFFF"/>
-                </a:solidFill>
-                <a:latin typeface="Poppins" panose="00000500000000000000" pitchFamily="2" charset="0"/>
-              </a:rPr>
-              <a:t>Zielsetzung</a:t>
-            </a:r>
-          </a:p>
-        </p:txBody>
-      </p:sp>
-      <p:sp>
-        <p:nvSpPr>
-          <p:cNvPr id="3" name="Rechteck: abgerundete Ecken 2">
-            <a:extLst>
-              <a:ext uri="{FF2B5EF4-FFF2-40B4-BE49-F238E27FC236}">
-                <a16:creationId xmlns:a16="http://schemas.microsoft.com/office/drawing/2014/main" id="{7CA9368E-1F91-AFCC-2943-D6EC7554D718}"/>
+          <p:cNvPr id="15" name="Rechteck: abgerundete Ecken 14">
+            <a:extLst>
+              <a:ext uri="{FF2B5EF4-FFF2-40B4-BE49-F238E27FC236}">
+                <a16:creationId xmlns:a16="http://schemas.microsoft.com/office/drawing/2014/main" id="{CE504900-72F5-85AD-42CA-D5F89F87E42F}"/>
               </a:ext>
             </a:extLst>
           </p:cNvPr>
@@ -7347,14 +7369,14 @@
         </p:nvSpPr>
         <p:spPr>
           <a:xfrm>
-            <a:off x="609600" y="1778000"/>
+            <a:off x="6045200" y="1778000"/>
             <a:ext cx="2489200" cy="3048000"/>
           </a:xfrm>
           <a:prstGeom prst="roundRect">
             <a:avLst/>
           </a:prstGeom>
           <a:solidFill>
-            <a:srgbClr val="1A1A1A"/>
+            <a:srgbClr val="111111"/>
           </a:solidFill>
           <a:ln w="12700">
             <a:solidFill>
@@ -7389,10 +7411,10 @@
       </p:sp>
       <p:sp>
         <p:nvSpPr>
-          <p:cNvPr id="4" name="Rechteck 3">
-            <a:extLst>
-              <a:ext uri="{FF2B5EF4-FFF2-40B4-BE49-F238E27FC236}">
-                <a16:creationId xmlns:a16="http://schemas.microsoft.com/office/drawing/2014/main" id="{E13A9D72-0A76-97D0-8B1E-2767FF71C929}"/>
+          <p:cNvPr id="14" name="Rechteck: abgerundete Ecken 13">
+            <a:extLst>
+              <a:ext uri="{FF2B5EF4-FFF2-40B4-BE49-F238E27FC236}">
+                <a16:creationId xmlns:a16="http://schemas.microsoft.com/office/drawing/2014/main" id="{A6371ABA-D11D-0018-9ACE-C9A9CC89DC55}"/>
               </a:ext>
             </a:extLst>
           </p:cNvPr>
@@ -7401,18 +7423,18 @@
         </p:nvSpPr>
         <p:spPr>
           <a:xfrm>
-            <a:off x="838200" y="2032000"/>
-            <a:ext cx="50800" cy="355600"/>
-          </a:xfrm>
-          <a:prstGeom prst="rect">
+            <a:off x="3327400" y="1778000"/>
+            <a:ext cx="2489200" cy="3048000"/>
+          </a:xfrm>
+          <a:prstGeom prst="roundRect">
             <a:avLst/>
           </a:prstGeom>
           <a:solidFill>
-            <a:srgbClr val="4C8BFF"/>
+            <a:srgbClr val="111111"/>
           </a:solidFill>
-          <a:ln w="0">
+          <a:ln w="12700">
             <a:solidFill>
-              <a:srgbClr val="4C8BFF"/>
+              <a:srgbClr val="222222"/>
             </a:solidFill>
           </a:ln>
         </p:spPr>
@@ -7443,50 +7465,10 @@
       </p:sp>
       <p:sp>
         <p:nvSpPr>
-          <p:cNvPr id="5" name="Textfeld 4">
-            <a:extLst>
-              <a:ext uri="{FF2B5EF4-FFF2-40B4-BE49-F238E27FC236}">
-                <a16:creationId xmlns:a16="http://schemas.microsoft.com/office/drawing/2014/main" id="{0D941843-9C60-3C04-DF7B-15FBDCF5ADC0}"/>
-              </a:ext>
-            </a:extLst>
-          </p:cNvPr>
-          <p:cNvSpPr txBox="1"/>
-          <p:nvPr/>
-        </p:nvSpPr>
-        <p:spPr>
-          <a:xfrm>
-            <a:off x="889000" y="2032000"/>
-            <a:ext cx="2209800" cy="923330"/>
-          </a:xfrm>
-          <a:prstGeom prst="rect">
-            <a:avLst/>
-          </a:prstGeom>
-          <a:noFill/>
-        </p:spPr>
-        <p:txBody>
-          <a:bodyPr vert="horz" wrap="square" rtlCol="0">
-            <a:noAutofit/>
-          </a:bodyPr>
-          <a:lstStyle/>
-          <a:p>
-            <a:r>
-              <a:rPr lang="de-DE" sz="1800" dirty="0">
-                <a:solidFill>
-                  <a:srgbClr val="FFFFFF"/>
-                </a:solidFill>
-                <a:latin typeface="Source Sans 3"/>
-              </a:rPr>
-              <a:t>Klare Verantwortlichkeiten pro Aufgabe</a:t>
-            </a:r>
-          </a:p>
-        </p:txBody>
-      </p:sp>
-      <p:sp>
-        <p:nvSpPr>
-          <p:cNvPr id="6" name="Rechteck: abgerundete Ecken 5">
-            <a:extLst>
-              <a:ext uri="{FF2B5EF4-FFF2-40B4-BE49-F238E27FC236}">
-                <a16:creationId xmlns:a16="http://schemas.microsoft.com/office/drawing/2014/main" id="{DAB60455-4279-46C2-0EB7-43A240E66A32}"/>
+          <p:cNvPr id="13" name="Rechteck: abgerundete Ecken 12">
+            <a:extLst>
+              <a:ext uri="{FF2B5EF4-FFF2-40B4-BE49-F238E27FC236}">
+                <a16:creationId xmlns:a16="http://schemas.microsoft.com/office/drawing/2014/main" id="{5650F401-7E35-FE89-7DA6-576EE2AC9768}"/>
               </a:ext>
             </a:extLst>
           </p:cNvPr>
@@ -7495,14 +7477,14 @@
         </p:nvSpPr>
         <p:spPr>
           <a:xfrm>
-            <a:off x="3327400" y="1778000"/>
+            <a:off x="609600" y="1778000"/>
             <a:ext cx="2489200" cy="3048000"/>
           </a:xfrm>
           <a:prstGeom prst="roundRect">
             <a:avLst/>
           </a:prstGeom>
           <a:solidFill>
-            <a:srgbClr val="1A1A1A"/>
+            <a:srgbClr val="111111"/>
           </a:solidFill>
           <a:ln w="12700">
             <a:solidFill>
@@ -7537,10 +7519,50 @@
       </p:sp>
       <p:sp>
         <p:nvSpPr>
-          <p:cNvPr id="7" name="Rechteck 6">
-            <a:extLst>
-              <a:ext uri="{FF2B5EF4-FFF2-40B4-BE49-F238E27FC236}">
-                <a16:creationId xmlns:a16="http://schemas.microsoft.com/office/drawing/2014/main" id="{F6F7C832-CA3B-9422-3488-F7CF083F4B37}"/>
+          <p:cNvPr id="2" name="Textfeld 1">
+            <a:extLst>
+              <a:ext uri="{FF2B5EF4-FFF2-40B4-BE49-F238E27FC236}">
+                <a16:creationId xmlns:a16="http://schemas.microsoft.com/office/drawing/2014/main" id="{5A1D0970-09E7-5792-FDDA-5C7C29B6A91F}"/>
+              </a:ext>
+            </a:extLst>
+          </p:cNvPr>
+          <p:cNvSpPr txBox="1"/>
+          <p:nvPr/>
+        </p:nvSpPr>
+        <p:spPr>
+          <a:xfrm>
+            <a:off x="609600" y="508000"/>
+            <a:ext cx="5486400" cy="615553"/>
+          </a:xfrm>
+          <a:prstGeom prst="rect">
+            <a:avLst/>
+          </a:prstGeom>
+          <a:noFill/>
+        </p:spPr>
+        <p:txBody>
+          <a:bodyPr vert="horz" wrap="square" rtlCol="0">
+            <a:noAutofit/>
+          </a:bodyPr>
+          <a:lstStyle/>
+          <a:p>
+            <a:r>
+              <a:rPr lang="de-DE" sz="3400" b="1">
+                <a:solidFill>
+                  <a:srgbClr val="FFFFFF"/>
+                </a:solidFill>
+                <a:latin typeface="Poppins" panose="00000500000000000000" pitchFamily="2" charset="0"/>
+              </a:rPr>
+              <a:t>Zielsetzung</a:t>
+            </a:r>
+          </a:p>
+        </p:txBody>
+      </p:sp>
+      <p:sp>
+        <p:nvSpPr>
+          <p:cNvPr id="4" name="Rechteck 3">
+            <a:extLst>
+              <a:ext uri="{FF2B5EF4-FFF2-40B4-BE49-F238E27FC236}">
+                <a16:creationId xmlns:a16="http://schemas.microsoft.com/office/drawing/2014/main" id="{E13A9D72-0A76-97D0-8B1E-2767FF71C929}"/>
               </a:ext>
             </a:extLst>
           </p:cNvPr>
@@ -7549,7 +7571,7 @@
         </p:nvSpPr>
         <p:spPr>
           <a:xfrm>
-            <a:off x="3556000" y="2032000"/>
+            <a:off x="838200" y="2032000"/>
             <a:ext cx="50800" cy="355600"/>
           </a:xfrm>
           <a:prstGeom prst="rect">
@@ -7591,10 +7613,10 @@
       </p:sp>
       <p:sp>
         <p:nvSpPr>
-          <p:cNvPr id="8" name="Textfeld 7">
-            <a:extLst>
-              <a:ext uri="{FF2B5EF4-FFF2-40B4-BE49-F238E27FC236}">
-                <a16:creationId xmlns:a16="http://schemas.microsoft.com/office/drawing/2014/main" id="{8788C1BD-07CC-BDA9-AFAF-99742208CEFC}"/>
+          <p:cNvPr id="5" name="Textfeld 4">
+            <a:extLst>
+              <a:ext uri="{FF2B5EF4-FFF2-40B4-BE49-F238E27FC236}">
+                <a16:creationId xmlns:a16="http://schemas.microsoft.com/office/drawing/2014/main" id="{0D941843-9C60-3C04-DF7B-15FBDCF5ADC0}"/>
               </a:ext>
             </a:extLst>
           </p:cNvPr>
@@ -7603,8 +7625,8 @@
         </p:nvSpPr>
         <p:spPr>
           <a:xfrm>
-            <a:off x="3606800" y="2032000"/>
-            <a:ext cx="2035534" cy="923330"/>
+            <a:off x="889000" y="2032000"/>
+            <a:ext cx="2026816" cy="923330"/>
           </a:xfrm>
           <a:prstGeom prst="rect">
             <a:avLst/>
@@ -7624,17 +7646,17 @@
                 </a:solidFill>
                 <a:latin typeface="Source Sans 3"/>
               </a:rPr>
-              <a:t>Schnellere Entscheidungen mit Live-Status</a:t>
-            </a:r>
-          </a:p>
-        </p:txBody>
-      </p:sp>
-      <p:sp>
-        <p:nvSpPr>
-          <p:cNvPr id="9" name="Rechteck: abgerundete Ecken 8">
-            <a:extLst>
-              <a:ext uri="{FF2B5EF4-FFF2-40B4-BE49-F238E27FC236}">
-                <a16:creationId xmlns:a16="http://schemas.microsoft.com/office/drawing/2014/main" id="{7EFDCDCA-9CFA-E30A-3339-A824BC1BA9BB}"/>
+              <a:t>Bessere Planung und Überblick</a:t>
+            </a:r>
+          </a:p>
+        </p:txBody>
+      </p:sp>
+      <p:sp>
+        <p:nvSpPr>
+          <p:cNvPr id="7" name="Rechteck 6">
+            <a:extLst>
+              <a:ext uri="{FF2B5EF4-FFF2-40B4-BE49-F238E27FC236}">
+                <a16:creationId xmlns:a16="http://schemas.microsoft.com/office/drawing/2014/main" id="{F6F7C832-CA3B-9422-3488-F7CF083F4B37}"/>
               </a:ext>
             </a:extLst>
           </p:cNvPr>
@@ -7643,18 +7665,18 @@
         </p:nvSpPr>
         <p:spPr>
           <a:xfrm>
-            <a:off x="6045200" y="1778000"/>
-            <a:ext cx="2489200" cy="3048000"/>
-          </a:xfrm>
-          <a:prstGeom prst="roundRect">
+            <a:off x="3556000" y="2032000"/>
+            <a:ext cx="50800" cy="355600"/>
+          </a:xfrm>
+          <a:prstGeom prst="rect">
             <a:avLst/>
           </a:prstGeom>
           <a:solidFill>
-            <a:srgbClr val="1A1A1A"/>
+            <a:srgbClr val="4C8BFF"/>
           </a:solidFill>
-          <a:ln w="12700">
+          <a:ln w="0">
             <a:solidFill>
-              <a:srgbClr val="222222"/>
+              <a:srgbClr val="4C8BFF"/>
             </a:solidFill>
           </a:ln>
         </p:spPr>
@@ -7685,6 +7707,46 @@
       </p:sp>
       <p:sp>
         <p:nvSpPr>
+          <p:cNvPr id="8" name="Textfeld 7">
+            <a:extLst>
+              <a:ext uri="{FF2B5EF4-FFF2-40B4-BE49-F238E27FC236}">
+                <a16:creationId xmlns:a16="http://schemas.microsoft.com/office/drawing/2014/main" id="{8788C1BD-07CC-BDA9-AFAF-99742208CEFC}"/>
+              </a:ext>
+            </a:extLst>
+          </p:cNvPr>
+          <p:cNvSpPr txBox="1"/>
+          <p:nvPr/>
+        </p:nvSpPr>
+        <p:spPr>
+          <a:xfrm>
+            <a:off x="3606800" y="2032000"/>
+            <a:ext cx="2035534" cy="609476"/>
+          </a:xfrm>
+          <a:prstGeom prst="rect">
+            <a:avLst/>
+          </a:prstGeom>
+          <a:noFill/>
+        </p:spPr>
+        <p:txBody>
+          <a:bodyPr vert="horz" wrap="square" rtlCol="0">
+            <a:noAutofit/>
+          </a:bodyPr>
+          <a:lstStyle/>
+          <a:p>
+            <a:r>
+              <a:rPr lang="de-DE" sz="1800" dirty="0">
+                <a:solidFill>
+                  <a:srgbClr val="FFFFFF"/>
+                </a:solidFill>
+                <a:latin typeface="Source Sans 3"/>
+              </a:rPr>
+              <a:t>Schnelle Kommunikation </a:t>
+            </a:r>
+          </a:p>
+        </p:txBody>
+      </p:sp>
+      <p:sp>
+        <p:nvSpPr>
           <p:cNvPr id="10" name="Rechteck 9">
             <a:extLst>
               <a:ext uri="{FF2B5EF4-FFF2-40B4-BE49-F238E27FC236}">
@@ -7751,8 +7813,8 @@
         </p:nvSpPr>
         <p:spPr>
           <a:xfrm>
-            <a:off x="6324600" y="1950941"/>
-            <a:ext cx="2006600" cy="1200329"/>
+            <a:off x="6350000" y="2005327"/>
+            <a:ext cx="2159000" cy="950004"/>
           </a:xfrm>
           <a:prstGeom prst="rect">
             <a:avLst/>
@@ -8952,7 +9014,7 @@
         </p:nvSpPr>
         <p:spPr>
           <a:xfrm>
-            <a:off x="4716016" y="3435091"/>
+            <a:off x="4716016" y="3362796"/>
             <a:ext cx="3848100" cy="2159000"/>
           </a:xfrm>
           <a:prstGeom prst="roundRect">
@@ -9006,7 +9068,7 @@
         </p:nvSpPr>
         <p:spPr>
           <a:xfrm>
-            <a:off x="609600" y="508000"/>
+            <a:off x="683568" y="335776"/>
             <a:ext cx="5486400" cy="615553"/>
           </a:xfrm>
           <a:prstGeom prst="rect">
@@ -9021,7 +9083,7 @@
           <a:lstStyle/>
           <a:p>
             <a:r>
-              <a:rPr lang="de-DE" sz="3400" b="1">
+              <a:rPr lang="de-DE" sz="3400" b="1" dirty="0">
                 <a:solidFill>
                   <a:srgbClr val="FFFFFF"/>
                 </a:solidFill>
@@ -9081,8 +9143,8 @@
           <a:bodyPr rtlCol="0" anchor="ctr"/>
           <a:lstStyle/>
           <a:p>
-            <a:pPr algn="ctr"/>
-            <a:endParaRPr lang="de-DE"/>
+            <a:pPr lvl="1" algn="ctr"/>
+            <a:endParaRPr lang="de-DE" dirty="0"/>
           </a:p>
         </p:txBody>
       </p:sp>
@@ -9115,7 +9177,7 @@
           <a:lstStyle/>
           <a:p>
             <a:r>
-              <a:rPr lang="de-DE" sz="1800" b="1">
+              <a:rPr lang="de-DE" sz="1800" b="1" dirty="0">
                 <a:solidFill>
                   <a:srgbClr val="FFFFFF"/>
                 </a:solidFill>
@@ -9128,10 +9190,10 @@
       </p:sp>
       <p:sp>
         <p:nvSpPr>
-          <p:cNvPr id="5" name="Rechteck 4">
-            <a:extLst>
-              <a:ext uri="{FF2B5EF4-FFF2-40B4-BE49-F238E27FC236}">
-                <a16:creationId xmlns:a16="http://schemas.microsoft.com/office/drawing/2014/main" id="{2D3F510A-0EE3-6DCF-46F2-A7DEBC90BD6D}"/>
+          <p:cNvPr id="7" name="Rechteck: abgerundete Ecken 6">
+            <a:extLst>
+              <a:ext uri="{FF2B5EF4-FFF2-40B4-BE49-F238E27FC236}">
+                <a16:creationId xmlns:a16="http://schemas.microsoft.com/office/drawing/2014/main" id="{643F99B9-18E8-52D6-701A-E4911EEE32E2}"/>
               </a:ext>
             </a:extLst>
           </p:cNvPr>
@@ -9140,14 +9202,14 @@
         </p:nvSpPr>
         <p:spPr>
           <a:xfrm>
-            <a:off x="783084" y="1735829"/>
-            <a:ext cx="3441700" cy="1270000"/>
-          </a:xfrm>
-          <a:prstGeom prst="rect">
+            <a:off x="4716016" y="1092839"/>
+            <a:ext cx="3848100" cy="2159000"/>
+          </a:xfrm>
+          <a:prstGeom prst="roundRect">
             <a:avLst/>
           </a:prstGeom>
           <a:solidFill>
-            <a:srgbClr val="1A1A1A"/>
+            <a:srgbClr val="111111"/>
           </a:solidFill>
           <a:ln w="12700">
             <a:solidFill>
@@ -9182,10 +9244,10 @@
       </p:sp>
       <p:sp>
         <p:nvSpPr>
-          <p:cNvPr id="6" name="Textfeld 5">
-            <a:extLst>
-              <a:ext uri="{FF2B5EF4-FFF2-40B4-BE49-F238E27FC236}">
-                <a16:creationId xmlns:a16="http://schemas.microsoft.com/office/drawing/2014/main" id="{6707108B-02E0-2996-FE50-2B1F20CB20D5}"/>
+          <p:cNvPr id="8" name="Textfeld 7">
+            <a:extLst>
+              <a:ext uri="{FF2B5EF4-FFF2-40B4-BE49-F238E27FC236}">
+                <a16:creationId xmlns:a16="http://schemas.microsoft.com/office/drawing/2014/main" id="{B8A01FC6-9EDA-D3AD-3C24-4544ADEE4FED}"/>
               </a:ext>
             </a:extLst>
           </p:cNvPr>
@@ -9194,8 +9256,8 @@
         </p:nvSpPr>
         <p:spPr>
           <a:xfrm>
-            <a:off x="783084" y="2116829"/>
-            <a:ext cx="3441700" cy="308418"/>
+            <a:off x="4919216" y="1245239"/>
+            <a:ext cx="3441700" cy="369332"/>
           </a:xfrm>
           <a:prstGeom prst="rect">
             <a:avLst/>
@@ -9208,25 +9270,24 @@
           </a:bodyPr>
           <a:lstStyle/>
           <a:p>
-            <a:pPr algn="ctr"/>
-            <a:r>
-              <a:rPr lang="de-DE" sz="1400">
-                <a:solidFill>
-                  <a:srgbClr val="999999"/>
+            <a:r>
+              <a:rPr lang="de-DE" sz="1800" b="1">
+                <a:solidFill>
+                  <a:srgbClr val="FFFFFF"/>
                 </a:solidFill>
                 <a:latin typeface="Source Sans 3"/>
               </a:rPr>
-              <a:t>Screenshot</a:t>
-            </a:r>
-          </a:p>
-        </p:txBody>
-      </p:sp>
-      <p:sp>
-        <p:nvSpPr>
-          <p:cNvPr id="7" name="Rechteck: abgerundete Ecken 6">
-            <a:extLst>
-              <a:ext uri="{FF2B5EF4-FFF2-40B4-BE49-F238E27FC236}">
-                <a16:creationId xmlns:a16="http://schemas.microsoft.com/office/drawing/2014/main" id="{643F99B9-18E8-52D6-701A-E4911EEE32E2}"/>
+              <a:t>Requests und Chats</a:t>
+            </a:r>
+          </a:p>
+        </p:txBody>
+      </p:sp>
+      <p:sp>
+        <p:nvSpPr>
+          <p:cNvPr id="11" name="Rechteck: abgerundete Ecken 10">
+            <a:extLst>
+              <a:ext uri="{FF2B5EF4-FFF2-40B4-BE49-F238E27FC236}">
+                <a16:creationId xmlns:a16="http://schemas.microsoft.com/office/drawing/2014/main" id="{2D141FB4-DEAA-F2FE-A786-FC2CDF098224}"/>
               </a:ext>
             </a:extLst>
           </p:cNvPr>
@@ -9235,7 +9296,7 @@
         </p:nvSpPr>
         <p:spPr>
           <a:xfrm>
-            <a:off x="4716016" y="1092839"/>
+            <a:off x="579884" y="3362796"/>
             <a:ext cx="3848100" cy="2159000"/>
           </a:xfrm>
           <a:prstGeom prst="roundRect">
@@ -9277,10 +9338,10 @@
       </p:sp>
       <p:sp>
         <p:nvSpPr>
-          <p:cNvPr id="8" name="Textfeld 7">
-            <a:extLst>
-              <a:ext uri="{FF2B5EF4-FFF2-40B4-BE49-F238E27FC236}">
-                <a16:creationId xmlns:a16="http://schemas.microsoft.com/office/drawing/2014/main" id="{B8A01FC6-9EDA-D3AD-3C24-4544ADEE4FED}"/>
+          <p:cNvPr id="12" name="Textfeld 11">
+            <a:extLst>
+              <a:ext uri="{FF2B5EF4-FFF2-40B4-BE49-F238E27FC236}">
+                <a16:creationId xmlns:a16="http://schemas.microsoft.com/office/drawing/2014/main" id="{377B4EDF-BD59-EE0F-F86C-C67007D19435}"/>
               </a:ext>
             </a:extLst>
           </p:cNvPr>
@@ -9289,7 +9350,7 @@
         </p:nvSpPr>
         <p:spPr>
           <a:xfrm>
-            <a:off x="4919216" y="1245239"/>
+            <a:off x="812800" y="3567615"/>
             <a:ext cx="3441700" cy="369332"/>
           </a:xfrm>
           <a:prstGeom prst="rect">
@@ -9304,77 +9365,23 @@
           <a:lstStyle/>
           <a:p>
             <a:r>
-              <a:rPr lang="de-DE" sz="1800" b="1">
+              <a:rPr lang="de-DE" sz="1800" b="1" dirty="0">
                 <a:solidFill>
                   <a:srgbClr val="FFFFFF"/>
                 </a:solidFill>
                 <a:latin typeface="Source Sans 3"/>
               </a:rPr>
-              <a:t>Requests und Chats</a:t>
-            </a:r>
-          </a:p>
-        </p:txBody>
-      </p:sp>
-      <p:sp>
-        <p:nvSpPr>
-          <p:cNvPr id="9" name="Rechteck 8">
-            <a:extLst>
-              <a:ext uri="{FF2B5EF4-FFF2-40B4-BE49-F238E27FC236}">
-                <a16:creationId xmlns:a16="http://schemas.microsoft.com/office/drawing/2014/main" id="{C89083B0-93C8-8D94-CF2B-C3B9F361D1B5}"/>
-              </a:ext>
-            </a:extLst>
-          </p:cNvPr>
-          <p:cNvSpPr/>
-          <p:nvPr/>
-        </p:nvSpPr>
-        <p:spPr>
-          <a:xfrm>
-            <a:off x="4919216" y="1727839"/>
-            <a:ext cx="3441700" cy="1270000"/>
-          </a:xfrm>
-          <a:prstGeom prst="rect">
-            <a:avLst/>
-          </a:prstGeom>
-          <a:solidFill>
-            <a:srgbClr val="1A1A1A"/>
-          </a:solidFill>
-          <a:ln w="12700">
-            <a:solidFill>
-              <a:srgbClr val="222222"/>
-            </a:solidFill>
-          </a:ln>
-        </p:spPr>
-        <p:style>
-          <a:lnRef idx="2">
-            <a:schemeClr val="accent1">
-              <a:shade val="15000"/>
-            </a:schemeClr>
-          </a:lnRef>
-          <a:fillRef idx="1">
-            <a:schemeClr val="accent1"/>
-          </a:fillRef>
-          <a:effectRef idx="0">
-            <a:schemeClr val="accent1"/>
-          </a:effectRef>
-          <a:fontRef idx="minor">
-            <a:schemeClr val="lt1"/>
-          </a:fontRef>
-        </p:style>
-        <p:txBody>
-          <a:bodyPr rtlCol="0" anchor="ctr"/>
-          <a:lstStyle/>
-          <a:p>
-            <a:pPr algn="ctr"/>
-            <a:endParaRPr lang="de-DE"/>
-          </a:p>
-        </p:txBody>
-      </p:sp>
-      <p:sp>
-        <p:nvSpPr>
-          <p:cNvPr id="10" name="Textfeld 9">
-            <a:extLst>
-              <a:ext uri="{FF2B5EF4-FFF2-40B4-BE49-F238E27FC236}">
-                <a16:creationId xmlns:a16="http://schemas.microsoft.com/office/drawing/2014/main" id="{185141B4-F3BE-892F-5085-5539D1AC1B37}"/>
+              <a:t>Dashboard KPIs</a:t>
+            </a:r>
+          </a:p>
+        </p:txBody>
+      </p:sp>
+      <p:sp>
+        <p:nvSpPr>
+          <p:cNvPr id="16" name="Textfeld 15">
+            <a:extLst>
+              <a:ext uri="{FF2B5EF4-FFF2-40B4-BE49-F238E27FC236}">
+                <a16:creationId xmlns:a16="http://schemas.microsoft.com/office/drawing/2014/main" id="{D6B791A3-7786-4199-FB56-ABBA7B543441}"/>
               </a:ext>
             </a:extLst>
           </p:cNvPr>
@@ -9383,8 +9390,8 @@
         </p:nvSpPr>
         <p:spPr>
           <a:xfrm>
-            <a:off x="4919216" y="2108839"/>
-            <a:ext cx="3441700" cy="308418"/>
+            <a:off x="4919216" y="3429813"/>
+            <a:ext cx="3441700" cy="369332"/>
           </a:xfrm>
           <a:prstGeom prst="rect">
             <a:avLst/>
@@ -9397,339 +9404,14 @@
           </a:bodyPr>
           <a:lstStyle/>
           <a:p>
-            <a:pPr algn="ctr"/>
-            <a:r>
-              <a:rPr lang="de-DE" sz="1400">
-                <a:solidFill>
-                  <a:srgbClr val="999999"/>
+            <a:r>
+              <a:rPr lang="de-DE" sz="1800" b="1">
+                <a:solidFill>
+                  <a:srgbClr val="FFFFFF"/>
                 </a:solidFill>
                 <a:latin typeface="Source Sans 3"/>
               </a:rPr>
-              <a:t>Screenshot</a:t>
-            </a:r>
-          </a:p>
-        </p:txBody>
-      </p:sp>
-      <p:sp>
-        <p:nvSpPr>
-          <p:cNvPr id="11" name="Rechteck: abgerundete Ecken 10">
-            <a:extLst>
-              <a:ext uri="{FF2B5EF4-FFF2-40B4-BE49-F238E27FC236}">
-                <a16:creationId xmlns:a16="http://schemas.microsoft.com/office/drawing/2014/main" id="{2D141FB4-DEAA-F2FE-A786-FC2CDF098224}"/>
-              </a:ext>
-            </a:extLst>
-          </p:cNvPr>
-          <p:cNvSpPr/>
-          <p:nvPr/>
-        </p:nvSpPr>
-        <p:spPr>
-          <a:xfrm>
-            <a:off x="579884" y="3415215"/>
-            <a:ext cx="3848100" cy="2159000"/>
-          </a:xfrm>
-          <a:prstGeom prst="roundRect">
-            <a:avLst/>
-          </a:prstGeom>
-          <a:solidFill>
-            <a:srgbClr val="111111"/>
-          </a:solidFill>
-          <a:ln w="12700">
-            <a:solidFill>
-              <a:srgbClr val="222222"/>
-            </a:solidFill>
-          </a:ln>
-        </p:spPr>
-        <p:style>
-          <a:lnRef idx="2">
-            <a:schemeClr val="accent1">
-              <a:shade val="15000"/>
-            </a:schemeClr>
-          </a:lnRef>
-          <a:fillRef idx="1">
-            <a:schemeClr val="accent1"/>
-          </a:fillRef>
-          <a:effectRef idx="0">
-            <a:schemeClr val="accent1"/>
-          </a:effectRef>
-          <a:fontRef idx="minor">
-            <a:schemeClr val="lt1"/>
-          </a:fontRef>
-        </p:style>
-        <p:txBody>
-          <a:bodyPr rtlCol="0" anchor="ctr"/>
-          <a:lstStyle/>
-          <a:p>
-            <a:pPr algn="ctr"/>
-            <a:endParaRPr lang="de-DE"/>
-          </a:p>
-        </p:txBody>
-      </p:sp>
-      <p:sp>
-        <p:nvSpPr>
-          <p:cNvPr id="12" name="Textfeld 11">
-            <a:extLst>
-              <a:ext uri="{FF2B5EF4-FFF2-40B4-BE49-F238E27FC236}">
-                <a16:creationId xmlns:a16="http://schemas.microsoft.com/office/drawing/2014/main" id="{377B4EDF-BD59-EE0F-F86C-C67007D19435}"/>
-              </a:ext>
-            </a:extLst>
-          </p:cNvPr>
-          <p:cNvSpPr txBox="1"/>
-          <p:nvPr/>
-        </p:nvSpPr>
-        <p:spPr>
-          <a:xfrm>
-            <a:off x="812800" y="3567615"/>
-            <a:ext cx="3441700" cy="369332"/>
-          </a:xfrm>
-          <a:prstGeom prst="rect">
-            <a:avLst/>
-          </a:prstGeom>
-          <a:noFill/>
-        </p:spPr>
-        <p:txBody>
-          <a:bodyPr vert="horz" wrap="square" rtlCol="0">
-            <a:noAutofit/>
-          </a:bodyPr>
-          <a:lstStyle/>
-          <a:p>
-            <a:r>
-              <a:rPr lang="de-DE" sz="1800" b="1">
-                <a:solidFill>
-                  <a:srgbClr val="FFFFFF"/>
-                </a:solidFill>
-                <a:latin typeface="Source Sans 3"/>
-              </a:rPr>
-              <a:t>Dashboard KPIs</a:t>
-            </a:r>
-          </a:p>
-        </p:txBody>
-      </p:sp>
-      <p:sp>
-        <p:nvSpPr>
-          <p:cNvPr id="13" name="Rechteck 12">
-            <a:extLst>
-              <a:ext uri="{FF2B5EF4-FFF2-40B4-BE49-F238E27FC236}">
-                <a16:creationId xmlns:a16="http://schemas.microsoft.com/office/drawing/2014/main" id="{1D97AB23-042B-20EF-231D-E575660540C0}"/>
-              </a:ext>
-            </a:extLst>
-          </p:cNvPr>
-          <p:cNvSpPr/>
-          <p:nvPr/>
-        </p:nvSpPr>
-        <p:spPr>
-          <a:xfrm>
-            <a:off x="770260" y="4050215"/>
-            <a:ext cx="3441700" cy="1270000"/>
-          </a:xfrm>
-          <a:prstGeom prst="rect">
-            <a:avLst/>
-          </a:prstGeom>
-          <a:solidFill>
-            <a:srgbClr val="1A1A1A"/>
-          </a:solidFill>
-          <a:ln w="12700">
-            <a:solidFill>
-              <a:srgbClr val="222222"/>
-            </a:solidFill>
-          </a:ln>
-        </p:spPr>
-        <p:style>
-          <a:lnRef idx="2">
-            <a:schemeClr val="accent1">
-              <a:shade val="15000"/>
-            </a:schemeClr>
-          </a:lnRef>
-          <a:fillRef idx="1">
-            <a:schemeClr val="accent1"/>
-          </a:fillRef>
-          <a:effectRef idx="0">
-            <a:schemeClr val="accent1"/>
-          </a:effectRef>
-          <a:fontRef idx="minor">
-            <a:schemeClr val="lt1"/>
-          </a:fontRef>
-        </p:style>
-        <p:txBody>
-          <a:bodyPr rtlCol="0" anchor="ctr"/>
-          <a:lstStyle/>
-          <a:p>
-            <a:pPr algn="ctr"/>
-            <a:endParaRPr lang="de-DE"/>
-          </a:p>
-        </p:txBody>
-      </p:sp>
-      <p:sp>
-        <p:nvSpPr>
-          <p:cNvPr id="14" name="Textfeld 13">
-            <a:extLst>
-              <a:ext uri="{FF2B5EF4-FFF2-40B4-BE49-F238E27FC236}">
-                <a16:creationId xmlns:a16="http://schemas.microsoft.com/office/drawing/2014/main" id="{53EEB51B-7C40-D7BC-A7D8-0AE1F254C837}"/>
-              </a:ext>
-            </a:extLst>
-          </p:cNvPr>
-          <p:cNvSpPr txBox="1"/>
-          <p:nvPr/>
-        </p:nvSpPr>
-        <p:spPr>
-          <a:xfrm>
-            <a:off x="812800" y="4431215"/>
-            <a:ext cx="3441700" cy="308418"/>
-          </a:xfrm>
-          <a:prstGeom prst="rect">
-            <a:avLst/>
-          </a:prstGeom>
-          <a:noFill/>
-        </p:spPr>
-        <p:txBody>
-          <a:bodyPr vert="horz" wrap="square" rtlCol="0">
-            <a:noAutofit/>
-          </a:bodyPr>
-          <a:lstStyle/>
-          <a:p>
-            <a:pPr algn="ctr"/>
-            <a:r>
-              <a:rPr lang="de-DE" sz="1400">
-                <a:solidFill>
-                  <a:srgbClr val="999999"/>
-                </a:solidFill>
-                <a:latin typeface="Source Sans 3"/>
-              </a:rPr>
-              <a:t>Screenshot</a:t>
-            </a:r>
-          </a:p>
-        </p:txBody>
-      </p:sp>
-      <p:sp>
-        <p:nvSpPr>
-          <p:cNvPr id="16" name="Textfeld 15">
-            <a:extLst>
-              <a:ext uri="{FF2B5EF4-FFF2-40B4-BE49-F238E27FC236}">
-                <a16:creationId xmlns:a16="http://schemas.microsoft.com/office/drawing/2014/main" id="{D6B791A3-7786-4199-FB56-ABBA7B543441}"/>
-              </a:ext>
-            </a:extLst>
-          </p:cNvPr>
-          <p:cNvSpPr txBox="1"/>
-          <p:nvPr/>
-        </p:nvSpPr>
-        <p:spPr>
-          <a:xfrm>
-            <a:off x="4919216" y="3587491"/>
-            <a:ext cx="3441700" cy="369332"/>
-          </a:xfrm>
-          <a:prstGeom prst="rect">
-            <a:avLst/>
-          </a:prstGeom>
-          <a:noFill/>
-        </p:spPr>
-        <p:txBody>
-          <a:bodyPr vert="horz" wrap="square" rtlCol="0">
-            <a:noAutofit/>
-          </a:bodyPr>
-          <a:lstStyle/>
-          <a:p>
-            <a:r>
-              <a:rPr lang="de-DE" sz="1800" b="1">
-                <a:solidFill>
-                  <a:srgbClr val="FFFFFF"/>
-                </a:solidFill>
-                <a:latin typeface="Source Sans 3"/>
-              </a:rPr>
               <a:t>Kalender und Planung</a:t>
-            </a:r>
-          </a:p>
-        </p:txBody>
-      </p:sp>
-      <p:sp>
-        <p:nvSpPr>
-          <p:cNvPr id="17" name="Rechteck 16">
-            <a:extLst>
-              <a:ext uri="{FF2B5EF4-FFF2-40B4-BE49-F238E27FC236}">
-                <a16:creationId xmlns:a16="http://schemas.microsoft.com/office/drawing/2014/main" id="{09529824-3880-7390-DDC3-2E7276D7E8E3}"/>
-              </a:ext>
-            </a:extLst>
-          </p:cNvPr>
-          <p:cNvSpPr/>
-          <p:nvPr/>
-        </p:nvSpPr>
-        <p:spPr>
-          <a:xfrm>
-            <a:off x="4919216" y="4070091"/>
-            <a:ext cx="3441700" cy="1270000"/>
-          </a:xfrm>
-          <a:prstGeom prst="rect">
-            <a:avLst/>
-          </a:prstGeom>
-          <a:solidFill>
-            <a:srgbClr val="1A1A1A"/>
-          </a:solidFill>
-          <a:ln w="12700">
-            <a:solidFill>
-              <a:srgbClr val="222222"/>
-            </a:solidFill>
-          </a:ln>
-        </p:spPr>
-        <p:style>
-          <a:lnRef idx="2">
-            <a:schemeClr val="accent1">
-              <a:shade val="15000"/>
-            </a:schemeClr>
-          </a:lnRef>
-          <a:fillRef idx="1">
-            <a:schemeClr val="accent1"/>
-          </a:fillRef>
-          <a:effectRef idx="0">
-            <a:schemeClr val="accent1"/>
-          </a:effectRef>
-          <a:fontRef idx="minor">
-            <a:schemeClr val="lt1"/>
-          </a:fontRef>
-        </p:style>
-        <p:txBody>
-          <a:bodyPr rtlCol="0" anchor="ctr"/>
-          <a:lstStyle/>
-          <a:p>
-            <a:pPr algn="ctr"/>
-            <a:endParaRPr lang="de-DE"/>
-          </a:p>
-        </p:txBody>
-      </p:sp>
-      <p:sp>
-        <p:nvSpPr>
-          <p:cNvPr id="18" name="Textfeld 17">
-            <a:extLst>
-              <a:ext uri="{FF2B5EF4-FFF2-40B4-BE49-F238E27FC236}">
-                <a16:creationId xmlns:a16="http://schemas.microsoft.com/office/drawing/2014/main" id="{1B51C303-949A-F0E5-4D4A-9FA565B006FE}"/>
-              </a:ext>
-            </a:extLst>
-          </p:cNvPr>
-          <p:cNvSpPr txBox="1"/>
-          <p:nvPr/>
-        </p:nvSpPr>
-        <p:spPr>
-          <a:xfrm>
-            <a:off x="4919216" y="4451091"/>
-            <a:ext cx="3441700" cy="308418"/>
-          </a:xfrm>
-          <a:prstGeom prst="rect">
-            <a:avLst/>
-          </a:prstGeom>
-          <a:noFill/>
-        </p:spPr>
-        <p:txBody>
-          <a:bodyPr vert="horz" wrap="square" rtlCol="0">
-            <a:noAutofit/>
-          </a:bodyPr>
-          <a:lstStyle/>
-          <a:p>
-            <a:pPr algn="ctr"/>
-            <a:r>
-              <a:rPr lang="de-DE" sz="1400">
-                <a:solidFill>
-                  <a:srgbClr val="999999"/>
-                </a:solidFill>
-                <a:latin typeface="Source Sans 3"/>
-              </a:rPr>
-              <a:t>Screenshot</a:t>
             </a:r>
           </a:p>
         </p:txBody>
@@ -9765,6 +9447,464 @@
               <a:t>6</a:t>
             </a:fld>
             <a:endParaRPr lang="de-DE" dirty="0"/>
+          </a:p>
+        </p:txBody>
+      </p:sp>
+      <p:sp>
+        <p:nvSpPr>
+          <p:cNvPr id="23" name="Textfeld 22">
+            <a:extLst>
+              <a:ext uri="{FF2B5EF4-FFF2-40B4-BE49-F238E27FC236}">
+                <a16:creationId xmlns:a16="http://schemas.microsoft.com/office/drawing/2014/main" id="{689ECC12-7A5F-F420-CDC1-AFB249EF9E1C}"/>
+              </a:ext>
+            </a:extLst>
+          </p:cNvPr>
+          <p:cNvSpPr txBox="1"/>
+          <p:nvPr/>
+        </p:nvSpPr>
+        <p:spPr>
+          <a:xfrm>
+            <a:off x="812800" y="1578205"/>
+            <a:ext cx="3441700" cy="1604927"/>
+          </a:xfrm>
+          <a:prstGeom prst="rect">
+            <a:avLst/>
+          </a:prstGeom>
+          <a:noFill/>
+        </p:spPr>
+        <p:txBody>
+          <a:bodyPr wrap="square" rtlCol="0">
+            <a:spAutoFit/>
+          </a:bodyPr>
+          <a:lstStyle/>
+          <a:p>
+            <a:pPr marL="285750" indent="-285750">
+              <a:buClr>
+                <a:srgbClr val="4072CE"/>
+              </a:buClr>
+              <a:buFont typeface="Arial" panose="020B0604020202020204" pitchFamily="34" charset="0"/>
+              <a:buChar char="•"/>
+            </a:pPr>
+            <a:r>
+              <a:rPr lang="de-DE" dirty="0">
+                <a:solidFill>
+                  <a:schemeClr val="bg1"/>
+                </a:solidFill>
+              </a:rPr>
+              <a:t>Task Erstellen</a:t>
+            </a:r>
+          </a:p>
+          <a:p>
+            <a:pPr marL="285750" indent="-285750">
+              <a:buClr>
+                <a:srgbClr val="4072CE"/>
+              </a:buClr>
+              <a:buFont typeface="Arial" panose="020B0604020202020204" pitchFamily="34" charset="0"/>
+              <a:buChar char="•"/>
+            </a:pPr>
+            <a:r>
+              <a:rPr lang="de-DE" dirty="0">
+                <a:solidFill>
+                  <a:schemeClr val="bg1"/>
+                </a:solidFill>
+              </a:rPr>
+              <a:t>Task bearbeiten</a:t>
+            </a:r>
+          </a:p>
+          <a:p>
+            <a:pPr marL="285750" indent="-285750">
+              <a:buClr>
+                <a:srgbClr val="4072CE"/>
+              </a:buClr>
+              <a:buFont typeface="Arial" panose="020B0604020202020204" pitchFamily="34" charset="0"/>
+              <a:buChar char="•"/>
+            </a:pPr>
+            <a:r>
+              <a:rPr lang="de-DE" dirty="0">
+                <a:solidFill>
+                  <a:schemeClr val="bg1"/>
+                </a:solidFill>
+              </a:rPr>
+              <a:t>Task löschen</a:t>
+            </a:r>
+          </a:p>
+          <a:p>
+            <a:pPr marL="285750" indent="-285750">
+              <a:buClr>
+                <a:srgbClr val="4072CE"/>
+              </a:buClr>
+              <a:buFont typeface="Arial" panose="020B0604020202020204" pitchFamily="34" charset="0"/>
+              <a:buChar char="•"/>
+            </a:pPr>
+            <a:r>
+              <a:rPr lang="de-DE" dirty="0">
+                <a:solidFill>
+                  <a:schemeClr val="bg1"/>
+                </a:solidFill>
+              </a:rPr>
+              <a:t>Task Details ansehen</a:t>
+            </a:r>
+          </a:p>
+          <a:p>
+            <a:pPr marL="285750" indent="-285750">
+              <a:buClr>
+                <a:srgbClr val="4072CE"/>
+              </a:buClr>
+              <a:buFont typeface="Arial" panose="020B0604020202020204" pitchFamily="34" charset="0"/>
+              <a:buChar char="•"/>
+            </a:pPr>
+            <a:r>
+              <a:rPr lang="de-DE" dirty="0">
+                <a:solidFill>
+                  <a:schemeClr val="bg1"/>
+                </a:solidFill>
+              </a:rPr>
+              <a:t>Task Status sortieren</a:t>
+            </a:r>
+          </a:p>
+          <a:p>
+            <a:pPr marL="285750" indent="-285750">
+              <a:buClr>
+                <a:srgbClr val="4072CE"/>
+              </a:buClr>
+              <a:buSzPct val="100000"/>
+              <a:buFont typeface="Arial" panose="020B0604020202020204" pitchFamily="34" charset="0"/>
+              <a:buChar char="•"/>
+            </a:pPr>
+            <a:r>
+              <a:rPr lang="de-DE" dirty="0">
+                <a:solidFill>
+                  <a:schemeClr val="bg1"/>
+                </a:solidFill>
+              </a:rPr>
+              <a:t>Arbeiter sortieren</a:t>
+            </a:r>
+          </a:p>
+          <a:p>
+            <a:pPr marL="285750" indent="-285750">
+              <a:buClr>
+                <a:srgbClr val="4072CE"/>
+              </a:buClr>
+              <a:buFont typeface="Arial" panose="020B0604020202020204" pitchFamily="34" charset="0"/>
+              <a:buChar char="•"/>
+            </a:pPr>
+            <a:r>
+              <a:rPr lang="de-DE" dirty="0">
+                <a:solidFill>
+                  <a:schemeClr val="bg1"/>
+                </a:solidFill>
+              </a:rPr>
+              <a:t>Zusätzliche Arbeiter nachfragen</a:t>
+            </a:r>
+          </a:p>
+        </p:txBody>
+      </p:sp>
+      <p:sp>
+        <p:nvSpPr>
+          <p:cNvPr id="24" name="Textfeld 23">
+            <a:extLst>
+              <a:ext uri="{FF2B5EF4-FFF2-40B4-BE49-F238E27FC236}">
+                <a16:creationId xmlns:a16="http://schemas.microsoft.com/office/drawing/2014/main" id="{DE41126C-4149-9B49-7EE9-B972DDF05146}"/>
+              </a:ext>
+            </a:extLst>
+          </p:cNvPr>
+          <p:cNvSpPr txBox="1"/>
+          <p:nvPr/>
+        </p:nvSpPr>
+        <p:spPr>
+          <a:xfrm>
+            <a:off x="4919216" y="1614571"/>
+            <a:ext cx="3441700" cy="1172757"/>
+          </a:xfrm>
+          <a:prstGeom prst="rect">
+            <a:avLst/>
+          </a:prstGeom>
+          <a:noFill/>
+        </p:spPr>
+        <p:txBody>
+          <a:bodyPr wrap="square" rtlCol="0">
+            <a:spAutoFit/>
+          </a:bodyPr>
+          <a:lstStyle/>
+          <a:p>
+            <a:pPr marL="285750" indent="-285750">
+              <a:buClr>
+                <a:srgbClr val="4072CE"/>
+              </a:buClr>
+              <a:buFont typeface="Arial" panose="020B0604020202020204" pitchFamily="34" charset="0"/>
+              <a:buChar char="•"/>
+            </a:pPr>
+            <a:r>
+              <a:rPr lang="de-DE" dirty="0">
+                <a:solidFill>
+                  <a:schemeClr val="bg1"/>
+                </a:solidFill>
+              </a:rPr>
+              <a:t>Bereich zum Annehmen / Ablehnen von Angeboten</a:t>
+            </a:r>
+          </a:p>
+          <a:p>
+            <a:pPr marL="285750" indent="-285750">
+              <a:buClr>
+                <a:srgbClr val="4072CE"/>
+              </a:buClr>
+              <a:buFont typeface="Arial" panose="020B0604020202020204" pitchFamily="34" charset="0"/>
+              <a:buChar char="•"/>
+            </a:pPr>
+            <a:r>
+              <a:rPr lang="de-DE" dirty="0">
+                <a:solidFill>
+                  <a:schemeClr val="bg1"/>
+                </a:solidFill>
+              </a:rPr>
+              <a:t>Gruppenchat mit Manager und Arbeitern </a:t>
+            </a:r>
+          </a:p>
+          <a:p>
+            <a:pPr marL="285750" indent="-285750">
+              <a:buClr>
+                <a:srgbClr val="4072CE"/>
+              </a:buClr>
+              <a:buFont typeface="Arial" panose="020B0604020202020204" pitchFamily="34" charset="0"/>
+              <a:buChar char="•"/>
+            </a:pPr>
+            <a:r>
+              <a:rPr lang="de-DE" dirty="0">
+                <a:solidFill>
+                  <a:schemeClr val="bg1"/>
+                </a:solidFill>
+              </a:rPr>
+              <a:t>Privat Chat mit Manager</a:t>
+            </a:r>
+          </a:p>
+        </p:txBody>
+      </p:sp>
+      <p:sp>
+        <p:nvSpPr>
+          <p:cNvPr id="25" name="Textfeld 24">
+            <a:extLst>
+              <a:ext uri="{FF2B5EF4-FFF2-40B4-BE49-F238E27FC236}">
+                <a16:creationId xmlns:a16="http://schemas.microsoft.com/office/drawing/2014/main" id="{CB6EA1D9-1C04-7396-8E88-460E7672E805}"/>
+              </a:ext>
+            </a:extLst>
+          </p:cNvPr>
+          <p:cNvSpPr txBox="1"/>
+          <p:nvPr/>
+        </p:nvSpPr>
+        <p:spPr>
+          <a:xfrm>
+            <a:off x="812800" y="3937620"/>
+            <a:ext cx="3441700" cy="1172757"/>
+          </a:xfrm>
+          <a:prstGeom prst="rect">
+            <a:avLst/>
+          </a:prstGeom>
+          <a:noFill/>
+        </p:spPr>
+        <p:txBody>
+          <a:bodyPr wrap="square" rtlCol="0">
+            <a:spAutoFit/>
+          </a:bodyPr>
+          <a:lstStyle/>
+          <a:p>
+            <a:pPr marL="285750" indent="-285750">
+              <a:buClr>
+                <a:srgbClr val="4072CE"/>
+              </a:buClr>
+              <a:buFont typeface="Arial" panose="020B0604020202020204" pitchFamily="34" charset="0"/>
+              <a:buChar char="•"/>
+            </a:pPr>
+            <a:r>
+              <a:rPr lang="de-DE" dirty="0">
+                <a:solidFill>
+                  <a:schemeClr val="bg1"/>
+                </a:solidFill>
+              </a:rPr>
+              <a:t>Task Erstellen</a:t>
+            </a:r>
+          </a:p>
+          <a:p>
+            <a:pPr marL="285750" indent="-285750">
+              <a:buClr>
+                <a:srgbClr val="4072CE"/>
+              </a:buClr>
+              <a:buFont typeface="Arial" panose="020B0604020202020204" pitchFamily="34" charset="0"/>
+              <a:buChar char="•"/>
+            </a:pPr>
+            <a:r>
+              <a:rPr lang="de-DE" dirty="0">
+                <a:solidFill>
+                  <a:schemeClr val="bg1"/>
+                </a:solidFill>
+              </a:rPr>
+              <a:t>Task Details ansehen</a:t>
+            </a:r>
+          </a:p>
+          <a:p>
+            <a:pPr marL="285750" indent="-285750">
+              <a:buClr>
+                <a:srgbClr val="4072CE"/>
+              </a:buClr>
+              <a:buFont typeface="Arial" panose="020B0604020202020204" pitchFamily="34" charset="0"/>
+              <a:buChar char="•"/>
+            </a:pPr>
+            <a:r>
+              <a:rPr lang="de-DE" dirty="0">
+                <a:solidFill>
+                  <a:schemeClr val="bg1"/>
+                </a:solidFill>
+              </a:rPr>
+              <a:t>Task Status sortieren</a:t>
+            </a:r>
+          </a:p>
+          <a:p>
+            <a:pPr marL="285750" indent="-285750">
+              <a:buClr>
+                <a:srgbClr val="4072CE"/>
+              </a:buClr>
+              <a:buSzPct val="100000"/>
+              <a:buFont typeface="Arial" panose="020B0604020202020204" pitchFamily="34" charset="0"/>
+              <a:buChar char="•"/>
+            </a:pPr>
+            <a:r>
+              <a:rPr lang="de-DE" dirty="0">
+                <a:solidFill>
+                  <a:schemeClr val="bg1"/>
+                </a:solidFill>
+              </a:rPr>
+              <a:t>Arbeiter sortieren</a:t>
+            </a:r>
+          </a:p>
+          <a:p>
+            <a:pPr marL="285750" indent="-285750">
+              <a:buClr>
+                <a:srgbClr val="4072CE"/>
+              </a:buClr>
+              <a:buFont typeface="Arial" panose="020B0604020202020204" pitchFamily="34" charset="0"/>
+              <a:buChar char="•"/>
+            </a:pPr>
+            <a:r>
+              <a:rPr lang="de-DE" dirty="0">
+                <a:solidFill>
+                  <a:schemeClr val="bg1"/>
+                </a:solidFill>
+              </a:rPr>
+              <a:t>Zusätzliche Arbeiter anfragen</a:t>
+            </a:r>
+          </a:p>
+        </p:txBody>
+      </p:sp>
+      <p:sp>
+        <p:nvSpPr>
+          <p:cNvPr id="26" name="Textfeld 25">
+            <a:extLst>
+              <a:ext uri="{FF2B5EF4-FFF2-40B4-BE49-F238E27FC236}">
+                <a16:creationId xmlns:a16="http://schemas.microsoft.com/office/drawing/2014/main" id="{F311834E-7C7F-93D5-42E0-A4F8ECA3905B}"/>
+              </a:ext>
+            </a:extLst>
+          </p:cNvPr>
+          <p:cNvSpPr txBox="1"/>
+          <p:nvPr/>
+        </p:nvSpPr>
+        <p:spPr>
+          <a:xfrm>
+            <a:off x="5006837" y="3858701"/>
+            <a:ext cx="3441700" cy="1388842"/>
+          </a:xfrm>
+          <a:prstGeom prst="rect">
+            <a:avLst/>
+          </a:prstGeom>
+          <a:noFill/>
+        </p:spPr>
+        <p:txBody>
+          <a:bodyPr wrap="square" rtlCol="0">
+            <a:spAutoFit/>
+          </a:bodyPr>
+          <a:lstStyle/>
+          <a:p>
+            <a:pPr marL="285750" indent="-285750">
+              <a:buClr>
+                <a:srgbClr val="4072CE"/>
+              </a:buClr>
+              <a:buFont typeface="Arial" panose="020B0604020202020204" pitchFamily="34" charset="0"/>
+              <a:buChar char="•"/>
+            </a:pPr>
+            <a:r>
+              <a:rPr lang="de-DE" dirty="0">
+                <a:solidFill>
+                  <a:schemeClr val="bg1"/>
+                </a:solidFill>
+              </a:rPr>
+              <a:t>Automatische Kalendereinträge</a:t>
+            </a:r>
+          </a:p>
+          <a:p>
+            <a:pPr marL="285750" indent="-285750">
+              <a:buClr>
+                <a:srgbClr val="4072CE"/>
+              </a:buClr>
+              <a:buFont typeface="Arial" panose="020B0604020202020204" pitchFamily="34" charset="0"/>
+              <a:buChar char="•"/>
+            </a:pPr>
+            <a:r>
+              <a:rPr lang="de-DE" dirty="0">
+                <a:solidFill>
+                  <a:schemeClr val="bg1"/>
+                </a:solidFill>
+              </a:rPr>
+              <a:t>Manager sehen alle Einträge</a:t>
+            </a:r>
+          </a:p>
+          <a:p>
+            <a:pPr marL="285750" indent="-285750">
+              <a:buClr>
+                <a:srgbClr val="4072CE"/>
+              </a:buClr>
+              <a:buFont typeface="Arial" panose="020B0604020202020204" pitchFamily="34" charset="0"/>
+              <a:buChar char="•"/>
+            </a:pPr>
+            <a:r>
+              <a:rPr lang="de-DE" dirty="0">
+                <a:solidFill>
+                  <a:schemeClr val="bg1"/>
+                </a:solidFill>
+              </a:rPr>
+              <a:t>Arbeiter sieht seine eigenen Tasks </a:t>
+            </a:r>
+          </a:p>
+          <a:p>
+            <a:pPr marL="285750" indent="-285750">
+              <a:buClr>
+                <a:srgbClr val="4072CE"/>
+              </a:buClr>
+              <a:buFont typeface="Arial" panose="020B0604020202020204" pitchFamily="34" charset="0"/>
+              <a:buChar char="•"/>
+            </a:pPr>
+            <a:r>
+              <a:rPr lang="de-DE" dirty="0">
+                <a:solidFill>
+                  <a:schemeClr val="bg1"/>
+                </a:solidFill>
+              </a:rPr>
+              <a:t>Live-Status der Arbeiter</a:t>
+            </a:r>
+          </a:p>
+          <a:p>
+            <a:pPr marL="285750" indent="-285750">
+              <a:buClr>
+                <a:srgbClr val="4072CE"/>
+              </a:buClr>
+              <a:buFont typeface="Arial" panose="020B0604020202020204" pitchFamily="34" charset="0"/>
+              <a:buChar char="•"/>
+            </a:pPr>
+            <a:r>
+              <a:rPr lang="de-DE" dirty="0">
+                <a:solidFill>
+                  <a:schemeClr val="bg1"/>
+                </a:solidFill>
+              </a:rPr>
+              <a:t>Arbeiter sehen Teammitglieder mit derselben Task </a:t>
+            </a:r>
           </a:p>
         </p:txBody>
       </p:sp>
@@ -10098,7 +10238,7 @@
             <a:r>
               <a:rPr lang="de-DE" sz="1200" b="1" dirty="0">
                 <a:solidFill>
-                  <a:srgbClr val="4C8BFF"/>
+                  <a:srgbClr val="4072CE"/>
                 </a:solidFill>
                 <a:latin typeface="Source Sans 3"/>
               </a:rPr>

</xml_diff>